<commit_message>
Business- en enterprise-architectuur fase 2: interactieve leesversie + toolbijlage
Reader/werkboek/docentenhandleiding/slidedeck per deel krijgen een interactieve
HTML-leesversie (tabs, downloadbox, vorige/volgende-navigatie) naast de bestaande
.docx/.pptx-downloads; index.html linkt nu naar reader.html per deel en bevat de
nieuwe Toolbijlage-sectie (Archi-referentiemateriaal).

Tijdens visuele QA (Word/PowerPoint-COM-render naar PDF/PNG) kwamen twee generieke
bugs in de bronconversie boven: "## "-kopregels (werkboek-secties en de
"Dagdeel A/B"-scheiders in delen 15/19/30) werden niet als kop herkend en de
"## Dagdeel"-scheiders lekten als losse tekst een naastgelegen pptx-slide in; een
ontbrekende bijschrift-dubbele punt in deel 23's [FIGUUR 23-1]-marker liet de
bijbehorende afbeelding in reader/slidedeck stilletjes wegvallen. Alle 30 delen
zijn na de fixes in convert-pptx.js opnieuw gegenereerd.

Co-Authored-By: Claude Sonnet 5 <noreply@anthropic.com>
</commit_message>
<xml_diff>
--- a/enterprise-architectuur/niveau-1/deel-01/slidedeck.pptx
+++ b/enterprise-architectuur/niveau-1/deel-01/slidedeck.pptx
@@ -4655,7 +4655,7 @@
       </p:sp>
       <p:pic>
         <p:nvPicPr>
-          <p:cNvPr id="3" name="Image 0" descr="c:\Projecten\eductus-trainingen\EnterpriseArchitectuur\_bouwstenen\figuren-generated\fig_1_2_domeinen.png">    </p:cNvPr>
+          <p:cNvPr id="3" name="Image 0" descr="C:\Projecten\eductus.nl\enterprise-architectuur\figuren\deel-01\fig_1_2_domeinen.png">    </p:cNvPr>
           <p:cNvPicPr>
             <a:picLocks noChangeAspect="1"/>
           </p:cNvPicPr>
@@ -5994,7 +5994,7 @@
       </p:sp>
       <p:pic>
         <p:nvPicPr>
-          <p:cNvPr id="3" name="Image 0" descr="c:\Projecten\eductus-trainingen\EnterpriseArchitectuur\_bouwstenen\figuren-generated\fig_1_3_stakeholder.png">    </p:cNvPr>
+          <p:cNvPr id="3" name="Image 0" descr="C:\Projecten\eductus.nl\enterprise-architectuur\figuren\deel-01\fig_1_3_stakeholder.png">    </p:cNvPr>
           <p:cNvPicPr>
             <a:picLocks noChangeAspect="1"/>
           </p:cNvPicPr>
@@ -9725,7 +9725,7 @@
       </p:sp>
       <p:pic>
         <p:nvPicPr>
-          <p:cNvPr id="3" name="Image 0" descr="c:\Projecten\eductus-trainingen\EnterpriseArchitectuur\_bouwstenen\figuren-generated\fig_1_1_tijdlijn.png">    </p:cNvPr>
+          <p:cNvPr id="3" name="Image 0" descr="C:\Projecten\eductus.nl\enterprise-architectuur\figuren\deel-01\fig_1_1_tijdlijn.png">    </p:cNvPr>
           <p:cNvPicPr>
             <a:picLocks noChangeAspect="1"/>
           </p:cNvPicPr>

</xml_diff>